<commit_message>
Tutorial 4 - Frontend Fundamentals
</commit_message>
<xml_diff>
--- a/slides/Tutorial 1 - API design.pptx
+++ b/slides/Tutorial 1 - API design.pptx
@@ -17,6 +17,7 @@
     <p:sldId id="266" r:id="rId11"/>
     <p:sldId id="267" r:id="rId12"/>
     <p:sldId id="268" r:id="rId13"/>
+    <p:sldId id="269" r:id="rId14"/>
   </p:sldIdLst>
   <p:sldSz cx="12192000" cy="6858000"/>
   <p:notesSz cx="6858000" cy="9144000"/>
@@ -115,6 +116,11 @@
       </a:defRPr>
     </a:lvl9pPr>
   </p:defaultTextStyle>
+  <p:extLst>
+    <p:ext uri="{EFAFB233-063F-42B5-8137-9DF3F51BA10A}">
+      <p15:sldGuideLst xmlns:p15="http://schemas.microsoft.com/office/powerpoint/2012/main"/>
+    </p:ext>
+  </p:extLst>
 </p:presentation>
 </file>
 
@@ -5467,13 +5473,13 @@
   <p:clrMapOvr>
     <a:masterClrMapping/>
   </p:clrMapOvr>
-  <mc:AlternateContent xmlns:mc="http://schemas.openxmlformats.org/markup-compatibility/2006">
-    <mc:Choice xmlns:p159="http://schemas.microsoft.com/office/powerpoint/2015/09/main" Requires="p159">
+  <mc:AlternateContent xmlns:mc="http://schemas.openxmlformats.org/markup-compatibility/2006" xmlns:p159="http://schemas.microsoft.com/office/powerpoint/2015/09/main">
+    <mc:Choice Requires="p159">
       <p:transition xmlns:p14="http://schemas.microsoft.com/office/powerpoint/2010/main" spd="slow" p14:dur="1500">
         <p159:morph option="byObject"/>
       </p:transition>
     </mc:Choice>
-    <mc:Fallback>
+    <mc:Fallback xmlns="">
       <p:transition spd="slow">
         <p:fade/>
       </p:transition>
@@ -8575,13 +8581,13 @@
   <p:clrMapOvr>
     <a:masterClrMapping/>
   </p:clrMapOvr>
-  <mc:AlternateContent xmlns:mc="http://schemas.openxmlformats.org/markup-compatibility/2006">
-    <mc:Choice xmlns:p159="http://schemas.microsoft.com/office/powerpoint/2015/09/main" Requires="p159">
+  <mc:AlternateContent xmlns:mc="http://schemas.openxmlformats.org/markup-compatibility/2006" xmlns:p159="http://schemas.microsoft.com/office/powerpoint/2015/09/main">
+    <mc:Choice Requires="p159">
       <p:transition xmlns:p14="http://schemas.microsoft.com/office/powerpoint/2010/main" spd="slow" p14:dur="1500">
         <p159:morph option="byObject"/>
       </p:transition>
     </mc:Choice>
-    <mc:Fallback>
+    <mc:Fallback xmlns="">
       <p:transition spd="slow">
         <p:fade/>
       </p:transition>
@@ -8801,13 +8807,13 @@
   <p:clrMapOvr>
     <a:masterClrMapping/>
   </p:clrMapOvr>
-  <mc:AlternateContent xmlns:mc="http://schemas.openxmlformats.org/markup-compatibility/2006">
-    <mc:Choice xmlns:p14="http://schemas.microsoft.com/office/powerpoint/2010/main" Requires="p14">
+  <mc:AlternateContent xmlns:mc="http://schemas.openxmlformats.org/markup-compatibility/2006" xmlns:p14="http://schemas.microsoft.com/office/powerpoint/2010/main">
+    <mc:Choice Requires="p14">
       <p:transition spd="slow" p14:dur="800">
         <p14:flythrough dir="out"/>
       </p:transition>
     </mc:Choice>
-    <mc:Fallback>
+    <mc:Fallback xmlns="">
       <p:transition spd="slow">
         <p:fade/>
       </p:transition>
@@ -8972,6 +8978,48 @@
       <p:bldP spid="4" grpId="0" uiExpand="1" build="p"/>
     </p:bldLst>
   </p:timing>
+</p:sld>
+</file>
+
+<file path=ppt/slides/slide13.xml><?xml version="1.0" encoding="utf-8"?>
+<p:sld xmlns:a="http://schemas.openxmlformats.org/drawingml/2006/main" xmlns:r="http://schemas.openxmlformats.org/officeDocument/2006/relationships" xmlns:p="http://schemas.openxmlformats.org/presentationml/2006/main">
+  <p:cSld>
+    <p:spTree>
+      <p:nvGrpSpPr>
+        <p:cNvPr id="1" name=""/>
+        <p:cNvGrpSpPr/>
+        <p:nvPr/>
+      </p:nvGrpSpPr>
+      <p:grpSpPr>
+        <a:xfrm>
+          <a:off x="0" y="0"/>
+          <a:ext cx="0" cy="0"/>
+          <a:chOff x="0" y="0"/>
+          <a:chExt cx="0" cy="0"/>
+        </a:xfrm>
+      </p:grpSpPr>
+    </p:spTree>
+    <p:extLst>
+      <p:ext uri="{BB962C8B-B14F-4D97-AF65-F5344CB8AC3E}">
+        <p14:creationId xmlns:p14="http://schemas.microsoft.com/office/powerpoint/2010/main" val="1064729232"/>
+      </p:ext>
+    </p:extLst>
+  </p:cSld>
+  <p:clrMapOvr>
+    <a:masterClrMapping/>
+  </p:clrMapOvr>
+  <mc:AlternateContent xmlns:mc="http://schemas.openxmlformats.org/markup-compatibility/2006" xmlns:p14="http://schemas.microsoft.com/office/powerpoint/2010/main">
+    <mc:Choice Requires="p14">
+      <p:transition spd="slow" p14:dur="800">
+        <p14:flythrough dir="out"/>
+      </p:transition>
+    </mc:Choice>
+    <mc:Fallback xmlns="">
+      <p:transition spd="slow">
+        <p:fade/>
+      </p:transition>
+    </mc:Fallback>
+  </mc:AlternateContent>
 </p:sld>
 </file>
 
@@ -15319,18 +15367,18 @@
       <p:bldP spid="11" grpId="0" animBg="1"/>
       <p:bldP spid="11" grpId="1" animBg="1"/>
       <p:bldP spid="12" grpId="0" animBg="1"/>
-      <p:bldP spid="12" grpId="1"/>
+      <p:bldP spid="12" grpId="1" animBg="1"/>
       <p:bldP spid="21" grpId="0" animBg="1"/>
       <p:bldP spid="22" grpId="0" animBg="1"/>
       <p:bldP spid="23" grpId="0" animBg="1"/>
-      <p:bldP spid="23" grpId="1"/>
+      <p:bldP spid="23" grpId="1" animBg="1"/>
       <p:bldP spid="24" grpId="0" animBg="1"/>
-      <p:bldP spid="24" grpId="1"/>
+      <p:bldP spid="24" grpId="1" animBg="1"/>
       <p:bldP spid="25" grpId="0" animBg="1"/>
       <p:bldP spid="26" grpId="0" animBg="1"/>
-      <p:bldP spid="26" grpId="1"/>
+      <p:bldP spid="26" grpId="1" animBg="1"/>
       <p:bldP spid="27" grpId="0" animBg="1"/>
-      <p:bldP spid="27" grpId="1"/>
+      <p:bldP spid="27" grpId="1" animBg="1"/>
       <p:bldP spid="28" grpId="0" animBg="1"/>
       <p:bldP spid="30" grpId="0" animBg="1"/>
     </p:bldLst>

</xml_diff>